<commit_message>
Reecrit les notes de presentation
</commit_message>
<xml_diff>
--- a/presentation/wasmredis-presentation_2.pptx
+++ b/presentation/wasmredis-presentation_2.pptx
@@ -512,7 +512,7 @@
           <a:lstStyle/>
           <a:p>
             <a:r>
-              <a:t>Je presente une base cle-valeur volontairement simple. Le coeur metier est en Go, compile en WebAssembly. React pilote le moteur sans serveur, et OPFS garde les donnees.</a:t>
+              <a:t>WasmRedis est une base clé-valeur locale. Le moteur est écrit en Go puis compilé en WebAssembly, et React sert à manipuler les données. Tout tourne dans le navigateur, sans serveur.</a:t>
             </a:r>
           </a:p>
         </p:txBody>
@@ -582,7 +582,7 @@
           <a:lstStyle/>
           <a:p>
             <a:r>
-              <a:t>Le calcul transforme scrollTop en startIndex et endIndex, avec huit lignes de marge. Le test utilise 100 000 entrees et ne depasse jamais 29 lignes. Chaque EntryRow s'abonne a une seule cle avec useSyncExternalStore, donc une edition ne reveille pas les autres.</a:t>
+              <a:t>firstVisible transforme scrollTop en index, puis startIndex recule de l’overscan sans passer sous zéro. visibleCount calcule les lignes utiles, endIndex les borne, et le retour donne la hauteur totale fictive. useEntry crée un abonnement et une lecture pour une seule clé, puis useSyncExternalStore les relie à React. Ça prouve qu’on limite les lignes montées et les composants réveillés. Je garde ces deux extraits parce qu’ils montrent les deux mécanismes complémentaires.</a:t>
             </a:r>
           </a:p>
         </p:txBody>
@@ -652,7 +652,7 @@
           <a:lstStyle/>
           <a:p>
             <a:r>
-              <a:t>Je termine par une demo courte : ajouter une cle avec TTL, forcer le flush, recharger, lancer Seed 100, filtrer value &gt;= 50, editer une ligne puis lancer Benchmark. Le dataset 100k existe dans le repo mais n'est pas charge par defaut sur ce petit PC.</a:t>
+              <a:t>Les quatre chiffres résument le résultat : le batch réduit le coût, le B-Tree garde les plages rapides, et la liste reste à 60 FPS avec 29 lignes DOM. La démo enchaîne un SET avec TTL, un flush, un rechargement, un filtre et une édition ciblée. Les tests Go, TypeScript et le build valident l’ensemble. Le dataset de 100 000 entrées reste disponible sans être chargé par défaut.</a:t>
             </a:r>
           </a:p>
         </p:txBody>
@@ -722,7 +722,7 @@
           <a:lstStyle/>
           <a:p>
             <a:r>
-              <a:t>Je pars d'un clic dans React. Le SDK valide puis envoie un message au worker. Le worker appelle Go/WASM. Go modifie le state et son buffer, puis le worker vide ce buffer dans OPFS. C'est la carte mentale a garder pour la suite.</a:t>
+              <a:t>Une commande part de React, passe par le SDK et le Worker, puis arrive au moteur Go/WASM. Le state répond vite en RAM. Les écritures passent par le buffer, puis dans l’AOF et le snapshot OPFS. Le travail lourd reste hors du thread de l’interface.</a:t>
             </a:r>
           </a:p>
         </p:txBody>
@@ -792,7 +792,7 @@
           <a:lstStyle/>
           <a:p>
             <a:r>
-              <a:t>Le schema montre le trajet depuis React jusqu'au moteur. La fonction affichee est le point d'entree Go expose a JavaScript : wasmRedisExecute verifie la requete, decode le JSON puis appelle Engine.ExecuteBatch. Le moteur et les acces OPFS restent dans le worker car les Sync Access Handles ne sont pas disponibles sur le main thread.</a:t>
+              <a:t>len(args) vérifie qu’une requête a été reçue ; sinon l’erreur missing request repart immédiatement. request prépare la structure Go, puis json.Unmarshal y décode le JSON et renvoie l’erreur si le format est invalide. La dernière ligne appelle engine.ExecuteBatch et encode sa réponse. Ça prouve que la frontière JavaScript-Go est contrôlée avant l’exécution. Je montre wasmRedisExecute parce que c’est le vrai point d’entrée WASM, pas un simple appelant.</a:t>
             </a:r>
           </a:p>
         </p:txBody>
@@ -862,7 +862,7 @@
           <a:lstStyle/>
           <a:p>
             <a:r>
-              <a:t>ParseCommand nettoie le texte puis lit le nom de commande. L'extrait garde la decision la plus interessante : pour GET, le parser distingue GET WHERE d'une lecture par cle. Le default montre aussi qu'une commande inconnue est rejetee avant le moteur.</a:t>
+              <a:t>strings.TrimSpace nettoie l’entrée, puis strings.Fields la découpe dans parts. ReadCommandName récupère le premier mot et le switch choisit le cas. Pour GET, EqualFold reconnaît WHERE ; sinon parseKeyCommand traite une lecture par clé. Le default renvoie l’erreur unknown command. Ça prouve que le texte est orienté ou rejeté avant le moteur. Je montre ParseCommand parce que c’est elle qui porte cette décision, pas les parseurs spécialisés.</a:t>
             </a:r>
           </a:p>
         </p:txBody>
@@ -932,7 +932,7 @@
           <a:lstStyle/>
           <a:p>
             <a:r>
-              <a:t>La fonction execute contient la decision importante : son switch choisit Set, Get ou Delete. Set et Delete modifient state et renvoient une Operation a persister, alors que Get renvoie seulement la valeur. Execute ajoutera ensuite ces operations au buffer. Les numeros de ligne sautent car seuls les trois cas utiles sont affiches.</a:t>
+              <a:t>switch command.Type choisit l’action. SET appelle SetWithTTL avec la clé, la valeur et le TTL. GET appelle getAndExpire, puis renvoie la valeur trouvée. DELETE retire la clé et renvoie une opération DELETE. Ça prouve que cette fonction relie une commande aux actions du moteur et aux écritures à conserver. Je montre execute parce que la décision est dans ce switch ; le reste n’ajoutait rien à la démonstration.</a:t>
             </a:r>
           </a:p>
         </p:txBody>
@@ -1002,7 +1002,7 @@
           <a:lstStyle/>
           <a:p>
             <a:r>
-              <a:t>restoreFromOpfs est la fonction centrale du redemarrage. Elle lit snapshot.json et le charge dans Go, puis lit aof.log, reconstruit les operations valides et les rejoue. Les lignes de validation secondaire sont coupees, mais chaque ligne visible vient du fichier indique. Les intervalles et tailles sont fournis par le fichier .env.</a:t>
+              <a:t>readOpfsText lit d’abord le fichier snapshot. S’il n’est pas vide et que le pont Go existe, wasmRedisLoadSnapshot recharge cet état. L’AOF est ensuite lu, découpé par ligne, filtré, puis chaque ligne est transformée depuis le JSON. S’il reste des opérations, replayGoOperations les rejoue. Ça prouve que le redémarrage applique le snapshot avant le journal. Je montre restoreFromOpfs parce que c’est elle qui contient cet ordre, pas une fonction de façade.</a:t>
             </a:r>
           </a:p>
         </p:txBody>
@@ -1072,7 +1072,7 @@
           <a:lstStyle/>
           <a:p>
             <a:r>
-              <a:t>ExecuteBatch prend un verrou pour qu'aucun autre batch ne s'intercale. La boucle execute chaque commande dans l'ordre, ajoute son resultat au meme index logique et rassemble les ecritures. Le benchmark mesure 15,5 fois moins de cout pour trente SET regroupes.</a:t>
+              <a:t>batchMu.Lock verrouille le lot, et defer garantit le déverrouillage. results et writes préparent les sorties. La boucle appelle ExecuteText pour chaque commande, puis ajoute résultat et écritures dans le même ordre. Le retour ajoute la taille du buffer. Ça prouve qu’un batch s’exécute d’un bloc avec des réponses alignées. Je montre ExecuteBatch parce que le verrou et l’alignement sont visibles ici.</a:t>
             </a:r>
           </a:p>
         </p:txBody>
@@ -1142,7 +1142,7 @@
           <a:lstStyle/>
           <a:p>
             <a:r>
-              <a:t>Pour une recherche inferieure, le B-Tree est parcouru dans l'ordre croissant. Des qu'une valeur ne correspond plus, la fonction retourne false et coupe le parcours. Le cas superieur fait la meme chose en sens inverse.</a:t>
+              <a:t>items prépare la liste résultat. Pour les opérateurs &lt; et &lt;=, walkAscending parcourt l’arbre dans l’ordre. Dès que matchesRange devient faux, return false arrête le parcours ; sinon l’item est ajouté et true continue. La fonction renvoie alors les éléments trouvés. Ça prouve qu’une plage ne visite pas inutilement tout le B-Tree. Je montre ce bloc parce que return false est la décision technique qui répond au titre.</a:t>
             </a:r>
           </a:p>
         </p:txBody>
@@ -1212,7 +1212,7 @@
           <a:lstStyle/>
           <a:p>
             <a:r>
-              <a:t>Une valeur garde une date ExpiresAt. Si elle est depassee, cette fonction retire la cle du state et des deux index. L'appelant cree ensuite une operation DELETE pour l'AOF. Une horloge injectable rend ce comportement testable sans attendre.</a:t>
+              <a:t>isExpired vérifie l’échéance ; si elle n’est pas dépassée, la fonction renvoie false. Sinon la clé est supprimée du state. Les index d’égalité et numérique sont nettoyés, puis true confirme la suppression. Ça prouve qu’une expiration garde le state et les deux index cohérents. Je montre cette fonction parce que la condition et les trois suppressions utiles sont réunies au même endroit.</a:t>
             </a:r>
           </a:p>
         </p:txBody>

</xml_diff>